<commit_message>
docs/ppt: update to Calibri 67pt, centered with equal margins
</commit_message>
<xml_diff>
--- a/actual_secrets_no_joke.pptx
+++ b/actual_secrets_no_joke.pptx
@@ -3090,31 +3090,14 @@
       <p:grpSpPr/>
       <p:sp>
         <p:nvSpPr>
-          <p:cNvPr id="2" name="Title 1"/>
-          <p:cNvSpPr>
-            <a:spLocks noGrp="1"/>
-          </p:cNvSpPr>
-          <p:nvPr>
-            <p:ph type="title"/>
-          </p:nvPr>
-        </p:nvSpPr>
-        <p:spPr/>
-        <p:txBody>
-          <a:bodyPr/>
-          <a:lstStyle/>
-          <a:p/>
-        </p:txBody>
-      </p:sp>
-      <p:sp>
-        <p:nvSpPr>
-          <p:cNvPr id="3" name="TextBox 2"/>
+          <p:cNvPr id="2" name="TextBox 1"/>
           <p:cNvSpPr txBox="1"/>
           <p:nvPr/>
         </p:nvSpPr>
         <p:spPr>
           <a:xfrm>
-            <a:off x="914400" y="1371600"/>
-            <a:ext cx="7315200" cy="1371600"/>
+            <a:off x="0" y="0"/>
+            <a:ext cx="9144000" cy="6858000"/>
           </a:xfrm>
           <a:prstGeom prst="rect">
             <a:avLst/>
@@ -3122,15 +3105,20 @@
           <a:noFill/>
         </p:spPr>
         <p:txBody>
-          <a:bodyPr wrap="none">
+          <a:bodyPr wrap="square" anchor="ctr" lIns="914400" rIns="914400" tIns="914400" bIns="914400">
             <a:spAutoFit/>
           </a:bodyPr>
           <a:lstStyle/>
-          <a:p/>
           <a:p>
             <a:pPr algn="ctr">
-              <a:defRPr sz="5000">
-                <a:latin typeface="Cambria"/>
+              <a:spcBef>
+                <a:spcPts val="0"/>
+              </a:spcBef>
+              <a:spcAft>
+                <a:spcPts val="0"/>
+              </a:spcAft>
+              <a:defRPr sz="6700">
+                <a:latin typeface="Calibri"/>
               </a:defRPr>
             </a:pPr>
             <a:r>

</xml_diff>